<commit_message>
Retake report and slide screenshots in the redesigned interface
Re-runs the 44 GUI test cases through the running app with a fresh test
account and replaces figures 4.3 to 4.55, updating the test rows whose
generated questions or scores changed. The team's Machine Learning run
keeps its original screenshots, now noted as taken before the final
visual design. Contents page numbers follow the 3 extra pages. Slides 7
and 8 get new screenshots fitted to their frames, with descriptive alt
text.

Co-Authored-By: Claude Opus 5.5 <noreply@anthropic.com>
</commit_message>
<xml_diff>
--- a/Smart_Study_Final_Submission.pptx
+++ b/Smart_Study_Final_Submission.pptx
@@ -10197,7 +10197,7 @@
                 </a:solidFill>
                 <a:latin typeface="Aptos"/>
               </a:rPr>
-              <a:t>59 ML-service tests and 49 backend tests pass, plus end-to-end runs on the Docker stack.</a:t>
+              <a:t>67 ML-service tests and 53 backend tests pass, plus end-to-end runs on the Docker stack.</a:t>
             </a:r>
           </a:p>
         </p:txBody>
@@ -20653,7 +20653,7 @@
       </p:sp>
       <p:pic>
         <p:nvPicPr>
-          <p:cNvPr id="30" name="Practice panel screenshot" descr="slide-practice.png"/>
+          <p:cNvPr id="30" name="Practice panel screenshot" descr="Take a test from your question bank: question type Both (6), 6 questions and a Start test button."/>
           <p:cNvPicPr>
             <a:picLocks noChangeAspect="1"/>
           </p:cNvPicPr>
@@ -20667,8 +20667,8 @@
         </p:blipFill>
         <p:spPr>
           <a:xfrm>
-            <a:off x="5778500" y="2133600"/>
-            <a:ext cx="5613400" cy="1092874"/>
+            <a:off x="5849297" y="2133600"/>
+            <a:ext cx="5471805" cy="1092874"/>
           </a:xfrm>
           <a:prstGeom prst="rect">
             <a:avLst/>
@@ -20682,7 +20682,7 @@
       </p:pic>
       <p:pic>
         <p:nvPicPr>
-          <p:cNvPr id="31" name="Test review screenshot" descr="slide-review.png"/>
+          <p:cNvPr id="31" name="Test review screenshot" descr="Test review of a written answer on Kruskal's algorithm: the answer, feedback, a 0% score and an AI-writing check of 37%, uncertain."/>
           <p:cNvPicPr>
             <a:picLocks noChangeAspect="1"/>
           </p:cNvPicPr>
@@ -20696,8 +20696,8 @@
         </p:blipFill>
         <p:spPr>
           <a:xfrm>
-            <a:off x="5778500" y="3340100"/>
-            <a:ext cx="5613400" cy="2076461"/>
+            <a:off x="5875492" y="3340100"/>
+            <a:ext cx="5419416" cy="2076461"/>
           </a:xfrm>
           <a:prstGeom prst="rect">
             <a:avLst/>
@@ -21501,7 +21501,7 @@
       </p:sp>
       <p:pic>
         <p:nvPicPr>
-          <p:cNvPr id="30" name="Authenticity result screenshot" descr="slide-authenticity.png"/>
+          <p:cNvPr id="30" name="Authenticity result screenshot" descr="Authenticity check of 7,260 characters: overall 42%, uncertain; section 3 likely AI-written at 68%, section 4 likely human-written at 34%."/>
           <p:cNvPicPr>
             <a:picLocks noChangeAspect="1"/>
           </p:cNvPicPr>
@@ -21515,8 +21515,8 @@
         </p:blipFill>
         <p:spPr>
           <a:xfrm>
-            <a:off x="749300" y="2133600"/>
-            <a:ext cx="5588000" cy="2531908"/>
+            <a:off x="1174464" y="2133600"/>
+            <a:ext cx="4737672" cy="2531908"/>
           </a:xfrm>
           <a:prstGeom prst="rect">
             <a:avLst/>

</xml_diff>